<commit_message>
Final Project Update: Linear Regression implemented, now to add Ridge
</commit_message>
<xml_diff>
--- a/Final Project Presentation _ Paul Allen.pptx
+++ b/Final Project Presentation _ Paul Allen.pptx
@@ -131,7 +131,7 @@
   <pc:docChgLst>
     <pc:chgData name="Allen, Paul Tyler - (paulallen)" userId="7258a782-1281-4098-87a8-18ee19f750c8" providerId="ADAL" clId="{4FCEF169-E1F9-4C70-A856-C82FA0F6E5A0}"/>
     <pc:docChg chg="undo custSel addSld modSld">
-      <pc:chgData name="Allen, Paul Tyler - (paulallen)" userId="7258a782-1281-4098-87a8-18ee19f750c8" providerId="ADAL" clId="{4FCEF169-E1F9-4C70-A856-C82FA0F6E5A0}" dt="2026-05-05T05:01:37.328" v="894" actId="1076"/>
+      <pc:chgData name="Allen, Paul Tyler - (paulallen)" userId="7258a782-1281-4098-87a8-18ee19f750c8" providerId="ADAL" clId="{4FCEF169-E1F9-4C70-A856-C82FA0F6E5A0}" dt="2026-05-05T16:57:42.093" v="895" actId="20577"/>
       <pc:docMkLst>
         <pc:docMk/>
       </pc:docMkLst>
@@ -159,7 +159,7 @@
         </pc:spChg>
       </pc:sldChg>
       <pc:sldChg chg="modSp new mod">
-        <pc:chgData name="Allen, Paul Tyler - (paulallen)" userId="7258a782-1281-4098-87a8-18ee19f750c8" providerId="ADAL" clId="{4FCEF169-E1F9-4C70-A856-C82FA0F6E5A0}" dt="2026-05-05T04:12:37.370" v="265" actId="403"/>
+        <pc:chgData name="Allen, Paul Tyler - (paulallen)" userId="7258a782-1281-4098-87a8-18ee19f750c8" providerId="ADAL" clId="{4FCEF169-E1F9-4C70-A856-C82FA0F6E5A0}" dt="2026-05-05T16:57:42.093" v="895" actId="20577"/>
         <pc:sldMkLst>
           <pc:docMk/>
           <pc:sldMk cId="3244640113" sldId="257"/>
@@ -173,7 +173,7 @@
           </ac:spMkLst>
         </pc:spChg>
         <pc:spChg chg="mod">
-          <ac:chgData name="Allen, Paul Tyler - (paulallen)" userId="7258a782-1281-4098-87a8-18ee19f750c8" providerId="ADAL" clId="{4FCEF169-E1F9-4C70-A856-C82FA0F6E5A0}" dt="2026-05-05T04:12:37.370" v="265" actId="403"/>
+          <ac:chgData name="Allen, Paul Tyler - (paulallen)" userId="7258a782-1281-4098-87a8-18ee19f750c8" providerId="ADAL" clId="{4FCEF169-E1F9-4C70-A856-C82FA0F6E5A0}" dt="2026-05-05T16:57:42.093" v="895" actId="20577"/>
           <ac:spMkLst>
             <pc:docMk/>
             <pc:sldMk cId="3244640113" sldId="257"/>
@@ -707,6 +707,13 @@
             <a:schemeClr val="lt1"/>
           </a:fontRef>
         </p:style>
+        <p:txBody>
+          <a:bodyPr/>
+          <a:lstStyle/>
+          <a:p>
+            <a:endParaRPr lang="en-US"/>
+          </a:p>
+        </p:txBody>
       </p:sp>
       <p:sp>
         <p:nvSpPr>
@@ -745,6 +752,13 @@
             <a:schemeClr val="lt1"/>
           </a:fontRef>
         </p:style>
+        <p:txBody>
+          <a:bodyPr/>
+          <a:lstStyle/>
+          <a:p>
+            <a:endParaRPr lang="en-US"/>
+          </a:p>
+        </p:txBody>
       </p:sp>
       <p:sp>
         <p:nvSpPr>
@@ -3395,6 +3409,13 @@
             <a:schemeClr val="lt1"/>
           </a:fontRef>
         </p:style>
+        <p:txBody>
+          <a:bodyPr/>
+          <a:lstStyle/>
+          <a:p>
+            <a:endParaRPr lang="en-US"/>
+          </a:p>
+        </p:txBody>
       </p:sp>
       <p:sp>
         <p:nvSpPr>
@@ -4688,15 +4709,15 @@
           <a:p>
             <a:r>
               <a:rPr lang="en-US" sz="3200" dirty="0"/>
-              <a:t>Can earthquake magnitude be predicted </a:t>
-            </a:r>
-            <a:r>
-              <a:rPr lang="en-US" sz="3200" dirty="0" err="1"/>
-              <a:t>fro</a:t>
+              <a:t>Can earthquake magnitude be </a:t>
+            </a:r>
+            <a:r>
+              <a:rPr lang="en-US" sz="3200"/>
+              <a:t>predicted from </a:t>
             </a:r>
             <a:r>
               <a:rPr lang="en-US" sz="3200" dirty="0"/>
-              <a:t> how an event was detected?</a:t>
+              <a:t>how an event was detected?</a:t>
             </a:r>
           </a:p>
           <a:p>

</xml_diff>